<commit_message>
Remove pin card and fix RTL periods.
</commit_message>
<xml_diff>
--- a/LIFTX-EMS-App-Guide.pptx
+++ b/LIFTX-EMS-App-Guide.pptx
@@ -3186,7 +3186,7 @@
           <a:bodyPr wrap="square" lIns="0" tIns="0" rIns="0" bIns="0" rtlCol="0" anchor="ctr"/>
           <a:lstStyle/>
           <a:p>
-            <a:pPr algn="r" indent="0" marL="0">
+            <a:pPr rtl="1" algn="r" indent="0" marL="0">
               <a:buNone/>
             </a:pPr>
             <a:r>
@@ -3225,7 +3225,7 @@
           <a:bodyPr wrap="square" lIns="0" tIns="0" rIns="0" bIns="0" rtlCol="0" anchor="t"/>
           <a:lstStyle/>
           <a:p>
-            <a:pPr algn="r" indent="0" marL="0">
+            <a:pPr rtl="1" algn="r" indent="0" marL="0">
               <a:buNone/>
             </a:pPr>
             <a:r>
@@ -3237,7 +3237,7 @@
                 <a:ea typeface="Tahoma" pitchFamily="34" charset="-122"/>
                 <a:cs typeface="Tahoma" pitchFamily="34" charset="-120"/>
               </a:rPr>
-              <a:t>با دکمه ایجاد جدید یک واحد لبه تازه می‌سازید و ساختمان، عنوان و توضیحات را برایش ثبت می‌کنید.</a:t>
+              <a:t>با دکمه ایجاد جدید یک واحد لبه تازه می‌سازید و ساختمان، عنوان و توضیحات را برایش ثبت می‌کنید.‏</a:t>
             </a:r>
             <a:endParaRPr lang="en-US" sz="1300" dirty="0"/>
           </a:p>
@@ -3311,7 +3311,7 @@
           <a:bodyPr wrap="square" lIns="0" tIns="0" rIns="0" bIns="0" rtlCol="0" anchor="ctr"/>
           <a:lstStyle/>
           <a:p>
-            <a:pPr algn="r" indent="0" marL="0">
+            <a:pPr rtl="1" algn="r" indent="0" marL="0">
               <a:buNone/>
             </a:pPr>
             <a:r>
@@ -3350,7 +3350,7 @@
           <a:bodyPr wrap="square" lIns="0" tIns="0" rIns="0" bIns="0" rtlCol="0" anchor="t"/>
           <a:lstStyle/>
           <a:p>
-            <a:pPr algn="r" indent="0" marL="0">
+            <a:pPr rtl="1" algn="r" indent="0" marL="0">
               <a:buNone/>
             </a:pPr>
             <a:r>
@@ -3362,7 +3362,7 @@
                 <a:ea typeface="Tahoma" pitchFamily="34" charset="-122"/>
                 <a:cs typeface="Tahoma" pitchFamily="34" charset="-120"/>
               </a:rPr>
-              <a:t>کادر فیلتر بر اساس عنوان کمک می‌کند بین واحدهای زیاد سریع همان مورد را پیدا کنید.</a:t>
+              <a:t>کادر فیلتر بر اساس عنوان کمک می‌کند بین واحدهای زیاد سریع همان مورد را پیدا کنید.‏</a:t>
             </a:r>
             <a:endParaRPr lang="en-US" sz="1300" dirty="0"/>
           </a:p>
@@ -3436,7 +3436,7 @@
           <a:bodyPr wrap="square" lIns="0" tIns="0" rIns="0" bIns="0" rtlCol="0" anchor="ctr"/>
           <a:lstStyle/>
           <a:p>
-            <a:pPr algn="r" indent="0" marL="0">
+            <a:pPr rtl="1" algn="r" indent="0" marL="0">
               <a:buNone/>
             </a:pPr>
             <a:r>
@@ -3475,7 +3475,7 @@
           <a:bodyPr wrap="square" lIns="0" tIns="0" rIns="0" bIns="0" rtlCol="0" anchor="t"/>
           <a:lstStyle/>
           <a:p>
-            <a:pPr algn="r" indent="0" marL="0">
+            <a:pPr rtl="1" algn="r" indent="0" marL="0">
               <a:buNone/>
             </a:pPr>
             <a:r>
@@ -3487,7 +3487,7 @@
                 <a:ea typeface="Tahoma" pitchFamily="34" charset="-122"/>
                 <a:cs typeface="Tahoma" pitchFamily="34" charset="-120"/>
               </a:rPr>
-              <a:t>اگر این سوییچ روشن باشد، واحدهایی که غیرفعال شده‌اند هم در جدول دیده می‌شوند.</a:t>
+              <a:t>اگر این سوییچ روشن باشد، واحدهایی که غیرفعال شده‌اند هم در جدول دیده می‌شوند.‏</a:t>
             </a:r>
             <a:endParaRPr lang="en-US" sz="1300" dirty="0"/>
           </a:p>
@@ -3561,7 +3561,7 @@
           <a:bodyPr wrap="square" lIns="0" tIns="0" rIns="0" bIns="0" rtlCol="0" anchor="ctr"/>
           <a:lstStyle/>
           <a:p>
-            <a:pPr algn="r" indent="0" marL="0">
+            <a:pPr rtl="1" algn="r" indent="0" marL="0">
               <a:buNone/>
             </a:pPr>
             <a:r>
@@ -3600,7 +3600,7 @@
           <a:bodyPr wrap="square" lIns="0" tIns="0" rIns="0" bIns="0" rtlCol="0" anchor="t"/>
           <a:lstStyle/>
           <a:p>
-            <a:pPr algn="r" indent="0" marL="0">
+            <a:pPr rtl="1" algn="r" indent="0" marL="0">
               <a:buNone/>
             </a:pPr>
             <a:r>
@@ -3612,7 +3612,7 @@
                 <a:ea typeface="Tahoma" pitchFamily="34" charset="-122"/>
                 <a:cs typeface="Tahoma" pitchFamily="34" charset="-120"/>
               </a:rPr>
-              <a:t>با این سوییچ فقط واحدهای متصل نمایش داده می‌شوند تا وضعیت شبکه را سریع‌تر ببینید.</a:t>
+              <a:t>با این سوییچ فقط واحدهای متصل نمایش داده می‌شوند تا وضعیت شبکه را سریع‌تر ببینید.‏</a:t>
             </a:r>
             <a:endParaRPr lang="en-US" sz="1300" dirty="0"/>
           </a:p>
@@ -3686,7 +3686,7 @@
           <a:bodyPr wrap="square" lIns="0" tIns="0" rIns="0" bIns="0" rtlCol="0" anchor="ctr"/>
           <a:lstStyle/>
           <a:p>
-            <a:pPr algn="r" indent="0" marL="0">
+            <a:pPr rtl="1" algn="r" indent="0" marL="0">
               <a:buNone/>
             </a:pPr>
             <a:r>
@@ -3725,7 +3725,7 @@
           <a:bodyPr wrap="square" lIns="0" tIns="0" rIns="0" bIns="0" rtlCol="0" anchor="t"/>
           <a:lstStyle/>
           <a:p>
-            <a:pPr algn="r" indent="0" marL="0">
+            <a:pPr rtl="1" algn="r" indent="0" marL="0">
               <a:buNone/>
             </a:pPr>
             <a:r>
@@ -3737,7 +3737,7 @@
                 <a:ea typeface="Tahoma" pitchFamily="34" charset="-122"/>
                 <a:cs typeface="Tahoma" pitchFamily="34" charset="-120"/>
               </a:rPr>
-              <a:t>تعداد ردیف هر صفحه را عوض کنید و با فلش‌ها بین صفحات فهرست جابه‌جا شوید.</a:t>
+              <a:t>تعداد ردیف هر صفحه را عوض کنید و با فلش‌ها بین صفحات فهرست جابه‌جا شوید.‏</a:t>
             </a:r>
             <a:endParaRPr lang="en-US" sz="1300" dirty="0"/>
           </a:p>
@@ -3811,7 +3811,7 @@
           <a:bodyPr wrap="square" lIns="0" tIns="0" rIns="0" bIns="0" rtlCol="0" anchor="ctr"/>
           <a:lstStyle/>
           <a:p>
-            <a:pPr algn="r" indent="0" marL="0">
+            <a:pPr rtl="1" algn="r" indent="0" marL="0">
               <a:buNone/>
             </a:pPr>
             <a:r>
@@ -3850,7 +3850,7 @@
           <a:bodyPr wrap="square" lIns="0" tIns="0" rIns="0" bIns="0" rtlCol="0" anchor="t"/>
           <a:lstStyle/>
           <a:p>
-            <a:pPr algn="r" indent="0" marL="0">
+            <a:pPr rtl="1" algn="r" indent="0" marL="0">
               <a:buNone/>
             </a:pPr>
             <a:r>
@@ -3862,7 +3862,7 @@
                 <a:ea typeface="Tahoma" pitchFamily="34" charset="-122"/>
                 <a:cs typeface="Tahoma" pitchFamily="34" charset="-120"/>
               </a:rPr>
-              <a:t>کد، ساختمان، عنوان، توضیحات، تاریخ ایجاد، فعال بودن و پین دسترسی سریع در هر ردیف آمده است.</a:t>
+              <a:t>کد، ساختمان، عنوان، توضیحات، تاریخ ایجاد، فعال بودن و پین دسترسی سریع در هر ردیف آمده است.‏</a:t>
             </a:r>
             <a:endParaRPr lang="en-US" sz="1300" dirty="0"/>
           </a:p>
@@ -3936,7 +3936,7 @@
           <a:bodyPr wrap="square" lIns="0" tIns="0" rIns="0" bIns="0" rtlCol="0" anchor="ctr"/>
           <a:lstStyle/>
           <a:p>
-            <a:pPr algn="r" indent="0" marL="0">
+            <a:pPr rtl="1" algn="r" indent="0" marL="0">
               <a:buNone/>
             </a:pPr>
             <a:r>
@@ -3975,7 +3975,7 @@
           <a:bodyPr wrap="square" lIns="0" tIns="0" rIns="0" bIns="0" rtlCol="0" anchor="t"/>
           <a:lstStyle/>
           <a:p>
-            <a:pPr algn="r" indent="0" marL="0">
+            <a:pPr rtl="1" algn="r" indent="0" marL="0">
               <a:buNone/>
             </a:pPr>
             <a:r>
@@ -3987,7 +3987,7 @@
                 <a:ea typeface="Tahoma" pitchFamily="34" charset="-122"/>
                 <a:cs typeface="Tahoma" pitchFamily="34" charset="-120"/>
               </a:rPr>
-              <a:t>آیکون مانیتور در ابتدای ردیف مشخص می‌کند واحد الان آنلاین است یا نه.</a:t>
+              <a:t>آیکون مانیتور در ابتدای ردیف مشخص می‌کند واحد الان آنلاین است یا نه.‏</a:t>
             </a:r>
             <a:endParaRPr lang="en-US" sz="1300" dirty="0"/>
           </a:p>
@@ -4061,7 +4061,7 @@
           <a:bodyPr wrap="square" lIns="0" tIns="0" rIns="0" bIns="0" rtlCol="0" anchor="ctr"/>
           <a:lstStyle/>
           <a:p>
-            <a:pPr algn="r" indent="0" marL="0">
+            <a:pPr rtl="1" algn="r" indent="0" marL="0">
               <a:buNone/>
             </a:pPr>
             <a:r>
@@ -4100,7 +4100,7 @@
           <a:bodyPr wrap="square" lIns="0" tIns="0" rIns="0" bIns="0" rtlCol="0" anchor="t"/>
           <a:lstStyle/>
           <a:p>
-            <a:pPr algn="r" indent="0" marL="0">
+            <a:pPr rtl="1" algn="r" indent="0" marL="0">
               <a:buNone/>
             </a:pPr>
             <a:r>
@@ -4112,7 +4112,7 @@
                 <a:ea typeface="Tahoma" pitchFamily="34" charset="-122"/>
                 <a:cs typeface="Tahoma" pitchFamily="34" charset="-120"/>
               </a:rPr>
-              <a:t>از همین جدول می‌توانید واحد را فعال یا غیرفعال کنید و به دسترسی سریع اضافه کنید.</a:t>
+              <a:t>از همین جدول می‌توانید واحد را فعال یا غیرفعال کنید و به دسترسی سریع اضافه کنید.‏</a:t>
             </a:r>
             <a:endParaRPr lang="en-US" sz="1300" dirty="0"/>
           </a:p>
@@ -4959,7 +4959,7 @@
           <a:bodyPr wrap="square" lIns="0" tIns="0" rIns="0" bIns="0" rtlCol="0" anchor="ctr"/>
           <a:lstStyle/>
           <a:p>
-            <a:pPr algn="r" indent="0" marL="0">
+            <a:pPr rtl="1" algn="r" indent="0" marL="0">
               <a:buNone/>
             </a:pPr>
             <a:r>
@@ -4998,7 +4998,7 @@
           <a:bodyPr wrap="square" lIns="0" tIns="0" rIns="0" bIns="0" rtlCol="0" anchor="t"/>
           <a:lstStyle/>
           <a:p>
-            <a:pPr algn="r" indent="0" marL="0">
+            <a:pPr rtl="1" algn="r" indent="0" marL="0">
               <a:buNone/>
             </a:pPr>
             <a:r>
@@ -5010,7 +5010,7 @@
                 <a:ea typeface="Tahoma" pitchFamily="34" charset="-122"/>
                 <a:cs typeface="Tahoma" pitchFamily="34" charset="-120"/>
               </a:rPr>
-              <a:t>ساختمان تازه را با نام، کد، آدرس و تعداد طبقات ثبت کنید تا بعداً واحد و سرور به آن وصل شود.</a:t>
+              <a:t>ساختمان تازه را با نام، کد، آدرس و تعداد طبقات ثبت کنید تا بعداً واحد و سرور به آن وصل شود.‏</a:t>
             </a:r>
             <a:endParaRPr lang="en-US" sz="1300" dirty="0"/>
           </a:p>
@@ -5084,7 +5084,7 @@
           <a:bodyPr wrap="square" lIns="0" tIns="0" rIns="0" bIns="0" rtlCol="0" anchor="ctr"/>
           <a:lstStyle/>
           <a:p>
-            <a:pPr algn="r" indent="0" marL="0">
+            <a:pPr rtl="1" algn="r" indent="0" marL="0">
               <a:buNone/>
             </a:pPr>
             <a:r>
@@ -5123,7 +5123,7 @@
           <a:bodyPr wrap="square" lIns="0" tIns="0" rIns="0" bIns="0" rtlCol="0" anchor="t"/>
           <a:lstStyle/>
           <a:p>
-            <a:pPr algn="r" indent="0" marL="0">
+            <a:pPr rtl="1" algn="r" indent="0" marL="0">
               <a:buNone/>
             </a:pPr>
             <a:r>
@@ -5135,7 +5135,7 @@
                 <a:ea typeface="Tahoma" pitchFamily="34" charset="-122"/>
                 <a:cs typeface="Tahoma" pitchFamily="34" charset="-120"/>
               </a:rPr>
-              <a:t>نام رسمی ساختمان در سامانه؛ معمولاً همان چیزی است که در گزارش‌ها و گروه‌بندی واحدها دیده می‌شود.</a:t>
+              <a:t>نام رسمی ساختمان در سامانه؛ معمولاً همان چیزی است که در گزارش‌ها و گروه‌بندی واحدها دیده می‌شود.‏</a:t>
             </a:r>
             <a:endParaRPr lang="en-US" sz="1300" dirty="0"/>
           </a:p>
@@ -5209,7 +5209,7 @@
           <a:bodyPr wrap="square" lIns="0" tIns="0" rIns="0" bIns="0" rtlCol="0" anchor="ctr"/>
           <a:lstStyle/>
           <a:p>
-            <a:pPr algn="r" indent="0" marL="0">
+            <a:pPr rtl="1" algn="r" indent="0" marL="0">
               <a:buNone/>
             </a:pPr>
             <a:r>
@@ -5248,7 +5248,7 @@
           <a:bodyPr wrap="square" lIns="0" tIns="0" rIns="0" bIns="0" rtlCol="0" anchor="t"/>
           <a:lstStyle/>
           <a:p>
-            <a:pPr algn="r" indent="0" marL="0">
+            <a:pPr rtl="1" algn="r" indent="0" marL="0">
               <a:buNone/>
             </a:pPr>
             <a:r>
@@ -5260,7 +5260,7 @@
                 <a:ea typeface="Tahoma" pitchFamily="34" charset="-122"/>
                 <a:cs typeface="Tahoma" pitchFamily="34" charset="-120"/>
               </a:rPr>
-              <a:t>کد کوتاه و یکتا مثل RNKPLC یا PLSHTL برای شناسایی سریع ساختمان در جدول‌ها و اتصال‌ها.</a:t>
+              <a:t>کد کوتاه و یکتا مثل RNKPLC یا PLSHTL برای شناسایی سریع ساختمان در جدول‌ها و اتصال‌ها.‏</a:t>
             </a:r>
             <a:endParaRPr lang="en-US" sz="1300" dirty="0"/>
           </a:p>
@@ -5334,7 +5334,7 @@
           <a:bodyPr wrap="square" lIns="0" tIns="0" rIns="0" bIns="0" rtlCol="0" anchor="ctr"/>
           <a:lstStyle/>
           <a:p>
-            <a:pPr algn="r" indent="0" marL="0">
+            <a:pPr rtl="1" algn="r" indent="0" marL="0">
               <a:buNone/>
             </a:pPr>
             <a:r>
@@ -5373,7 +5373,7 @@
           <a:bodyPr wrap="square" lIns="0" tIns="0" rIns="0" bIns="0" rtlCol="0" anchor="t"/>
           <a:lstStyle/>
           <a:p>
-            <a:pPr algn="r" indent="0" marL="0">
+            <a:pPr rtl="1" algn="r" indent="0" marL="0">
               <a:buNone/>
             </a:pPr>
             <a:r>
@@ -5385,7 +5385,7 @@
                 <a:ea typeface="Tahoma" pitchFamily="34" charset="-122"/>
                 <a:cs typeface="Tahoma" pitchFamily="34" charset="-120"/>
               </a:rPr>
-              <a:t>نشانی ثبت‌شده ساختمان، به فارسی یا انگلیسی، برای پیدا کردن محل روی نقشه یا در پشتیبانی.</a:t>
+              <a:t>نشانی ثبت‌شده ساختمان، به فارسی یا انگلیسی، برای پیدا کردن محل روی نقشه یا در پشتیبانی.‏</a:t>
             </a:r>
             <a:endParaRPr lang="en-US" sz="1300" dirty="0"/>
           </a:p>
@@ -5459,7 +5459,7 @@
           <a:bodyPr wrap="square" lIns="0" tIns="0" rIns="0" bIns="0" rtlCol="0" anchor="ctr"/>
           <a:lstStyle/>
           <a:p>
-            <a:pPr algn="r" indent="0" marL="0">
+            <a:pPr rtl="1" algn="r" indent="0" marL="0">
               <a:buNone/>
             </a:pPr>
             <a:r>
@@ -5498,7 +5498,7 @@
           <a:bodyPr wrap="square" lIns="0" tIns="0" rIns="0" bIns="0" rtlCol="0" anchor="t"/>
           <a:lstStyle/>
           <a:p>
-            <a:pPr algn="r" indent="0" marL="0">
+            <a:pPr rtl="1" algn="r" indent="0" marL="0">
               <a:buNone/>
             </a:pPr>
             <a:r>
@@ -5510,7 +5510,7 @@
                 <a:ea typeface="Tahoma" pitchFamily="34" charset="-122"/>
                 <a:cs typeface="Tahoma" pitchFamily="34" charset="-120"/>
               </a:rPr>
-              <a:t>تعداد طبقات ثبت‌شده همان ساختمان؛ برای درک مقیاس پروژه و ظرفیت آسانسور مفید است.</a:t>
+              <a:t>تعداد طبقات ثبت‌شده همان ساختمان؛ برای درک مقیاس پروژه و ظرفیت آسانسور مفید است.‏</a:t>
             </a:r>
             <a:endParaRPr lang="en-US" sz="1300" dirty="0"/>
           </a:p>
@@ -5584,7 +5584,7 @@
           <a:bodyPr wrap="square" lIns="0" tIns="0" rIns="0" bIns="0" rtlCol="0" anchor="ctr"/>
           <a:lstStyle/>
           <a:p>
-            <a:pPr algn="r" indent="0" marL="0">
+            <a:pPr rtl="1" algn="r" indent="0" marL="0">
               <a:buNone/>
             </a:pPr>
             <a:r>
@@ -5623,7 +5623,7 @@
           <a:bodyPr wrap="square" lIns="0" tIns="0" rIns="0" bIns="0" rtlCol="0" anchor="t"/>
           <a:lstStyle/>
           <a:p>
-            <a:pPr algn="r" indent="0" marL="0">
+            <a:pPr rtl="1" algn="r" indent="0" marL="0">
               <a:buNone/>
             </a:pPr>
             <a:r>
@@ -5635,7 +5635,7 @@
                 <a:ea typeface="Tahoma" pitchFamily="34" charset="-122"/>
                 <a:cs typeface="Tahoma" pitchFamily="34" charset="-120"/>
               </a:rPr>
-              <a:t>برچسب‌هایی مثل E14 یا E19 نشان می‌دهند کدام واحدها به این ساختمان وصل شده‌اند.</a:t>
+              <a:t>برچسب‌هایی مثل E14 یا E19 نشان می‌دهند کدام واحدها به این ساختمان وصل شده‌اند.‏</a:t>
             </a:r>
             <a:endParaRPr lang="en-US" sz="1300" dirty="0"/>
           </a:p>
@@ -5709,7 +5709,7 @@
           <a:bodyPr wrap="square" lIns="0" tIns="0" rIns="0" bIns="0" rtlCol="0" anchor="ctr"/>
           <a:lstStyle/>
           <a:p>
-            <a:pPr algn="r" indent="0" marL="0">
+            <a:pPr rtl="1" algn="r" indent="0" marL="0">
               <a:buNone/>
             </a:pPr>
             <a:r>
@@ -5748,7 +5748,7 @@
           <a:bodyPr wrap="square" lIns="0" tIns="0" rIns="0" bIns="0" rtlCol="0" anchor="t"/>
           <a:lstStyle/>
           <a:p>
-            <a:pPr algn="r" indent="0" marL="0">
+            <a:pPr rtl="1" algn="r" indent="0" marL="0">
               <a:buNone/>
             </a:pPr>
             <a:r>
@@ -5760,7 +5760,7 @@
                 <a:ea typeface="Tahoma" pitchFamily="34" charset="-122"/>
                 <a:cs typeface="Tahoma" pitchFamily="34" charset="-120"/>
               </a:rPr>
-              <a:t>زمان ثبت ساختمان در سامانه تا سابقه تغییرات مشخص بماند.</a:t>
+              <a:t>زمان ثبت ساختمان در سامانه تا سابقه تغییرات مشخص بماند.‏</a:t>
             </a:r>
             <a:endParaRPr lang="en-US" sz="1300" dirty="0"/>
           </a:p>
@@ -5834,7 +5834,7 @@
           <a:bodyPr wrap="square" lIns="0" tIns="0" rIns="0" bIns="0" rtlCol="0" anchor="ctr"/>
           <a:lstStyle/>
           <a:p>
-            <a:pPr algn="r" indent="0" marL="0">
+            <a:pPr rtl="1" algn="r" indent="0" marL="0">
               <a:buNone/>
             </a:pPr>
             <a:r>
@@ -5873,7 +5873,7 @@
           <a:bodyPr wrap="square" lIns="0" tIns="0" rIns="0" bIns="0" rtlCol="0" anchor="t"/>
           <a:lstStyle/>
           <a:p>
-            <a:pPr algn="r" indent="0" marL="0">
+            <a:pPr rtl="1" algn="r" indent="0" marL="0">
               <a:buNone/>
             </a:pPr>
             <a:r>
@@ -5885,7 +5885,7 @@
                 <a:ea typeface="Tahoma" pitchFamily="34" charset="-122"/>
                 <a:cs typeface="Tahoma" pitchFamily="34" charset="-120"/>
               </a:rPr>
-              <a:t>قبل از ساخت واحد لبه یا سرور محلی، ساختمان باید اینجا تعریف شده باشد.</a:t>
+              <a:t>قبل از ساخت واحد لبه یا سرور محلی، ساختمان باید اینجا تعریف شده باشد.‏</a:t>
             </a:r>
             <a:endParaRPr lang="en-US" sz="1300" dirty="0"/>
           </a:p>
@@ -6732,7 +6732,7 @@
           <a:bodyPr wrap="square" lIns="0" tIns="0" rIns="0" bIns="0" rtlCol="0" anchor="ctr"/>
           <a:lstStyle/>
           <a:p>
-            <a:pPr algn="r" indent="0" marL="0">
+            <a:pPr rtl="1" algn="r" indent="0" marL="0">
               <a:buNone/>
             </a:pPr>
             <a:r>
@@ -6771,7 +6771,7 @@
           <a:bodyPr wrap="square" lIns="0" tIns="0" rIns="0" bIns="0" rtlCol="0" anchor="t"/>
           <a:lstStyle/>
           <a:p>
-            <a:pPr algn="r" indent="0" marL="0">
+            <a:pPr rtl="1" algn="r" indent="0" marL="0">
               <a:buNone/>
             </a:pPr>
             <a:r>
@@ -6783,7 +6783,7 @@
                 <a:ea typeface="Tahoma" pitchFamily="34" charset="-122"/>
                 <a:cs typeface="Tahoma" pitchFamily="34" charset="-120"/>
               </a:rPr>
-              <a:t>سرور محلی تازه را بسازید و ساختمان مربوط را برایش انتخاب کنید.</a:t>
+              <a:t>سرور محلی تازه را بسازید و ساختمان مربوط را برایش انتخاب کنید.‏</a:t>
             </a:r>
             <a:endParaRPr lang="en-US" sz="1300" dirty="0"/>
           </a:p>
@@ -6857,7 +6857,7 @@
           <a:bodyPr wrap="square" lIns="0" tIns="0" rIns="0" bIns="0" rtlCol="0" anchor="ctr"/>
           <a:lstStyle/>
           <a:p>
-            <a:pPr algn="r" indent="0" marL="0">
+            <a:pPr rtl="1" algn="r" indent="0" marL="0">
               <a:buNone/>
             </a:pPr>
             <a:r>
@@ -6896,7 +6896,7 @@
           <a:bodyPr wrap="square" lIns="0" tIns="0" rIns="0" bIns="0" rtlCol="0" anchor="t"/>
           <a:lstStyle/>
           <a:p>
-            <a:pPr algn="r" indent="0" marL="0">
+            <a:pPr rtl="1" algn="r" indent="0" marL="0">
               <a:buNone/>
             </a:pPr>
             <a:r>
@@ -6908,7 +6908,7 @@
                 <a:ea typeface="Tahoma" pitchFamily="34" charset="-122"/>
                 <a:cs typeface="Tahoma" pitchFamily="34" charset="-120"/>
               </a:rPr>
-              <a:t>نام خوانا مثل Palladium North Local Server تا تیم فنی سریع بفهمد این سرور مال کدام بخش است.</a:t>
+              <a:t>نام خوانا مثل Palladium North Local Server تا تیم فنی سریع بفهمد این سرور مال کدام بخش است.‏</a:t>
             </a:r>
             <a:endParaRPr lang="en-US" sz="1300" dirty="0"/>
           </a:p>
@@ -6982,7 +6982,7 @@
           <a:bodyPr wrap="square" lIns="0" tIns="0" rIns="0" bIns="0" rtlCol="0" anchor="ctr"/>
           <a:lstStyle/>
           <a:p>
-            <a:pPr algn="r" indent="0" marL="0">
+            <a:pPr rtl="1" algn="r" indent="0" marL="0">
               <a:buNone/>
             </a:pPr>
             <a:r>
@@ -7021,7 +7021,7 @@
           <a:bodyPr wrap="square" lIns="0" tIns="0" rIns="0" bIns="0" rtlCol="0" anchor="t"/>
           <a:lstStyle/>
           <a:p>
-            <a:pPr algn="r" indent="0" marL="0">
+            <a:pPr rtl="1" algn="r" indent="0" marL="0">
               <a:buNone/>
             </a:pPr>
             <a:r>
@@ -7033,7 +7033,7 @@
                 <a:ea typeface="Tahoma" pitchFamily="34" charset="-122"/>
                 <a:cs typeface="Tahoma" pitchFamily="34" charset="-120"/>
               </a:rPr>
-              <a:t>مشخص می‌کند سرور مال کدام ساختمان است. اگر ساختمان نداشته باشد، معمولاً N/A دیده می‌شود.</a:t>
+              <a:t>مشخص می‌کند سرور مال کدام ساختمان است.‏ اگر ساختمان نداشته باشد، معمولاً N/A دیده می‌شود.‏</a:t>
             </a:r>
             <a:endParaRPr lang="en-US" sz="1300" dirty="0"/>
           </a:p>
@@ -7107,7 +7107,7 @@
           <a:bodyPr wrap="square" lIns="0" tIns="0" rIns="0" bIns="0" rtlCol="0" anchor="ctr"/>
           <a:lstStyle/>
           <a:p>
-            <a:pPr algn="r" indent="0" marL="0">
+            <a:pPr rtl="1" algn="r" indent="0" marL="0">
               <a:buNone/>
             </a:pPr>
             <a:r>
@@ -7146,7 +7146,7 @@
           <a:bodyPr wrap="square" lIns="0" tIns="0" rIns="0" bIns="0" rtlCol="0" anchor="t"/>
           <a:lstStyle/>
           <a:p>
-            <a:pPr algn="r" indent="0" marL="0">
+            <a:pPr rtl="1" algn="r" indent="0" marL="0">
               <a:buNone/>
             </a:pPr>
             <a:r>
@@ -7158,7 +7158,7 @@
                 <a:ea typeface="Tahoma" pitchFamily="34" charset="-122"/>
                 <a:cs typeface="Tahoma" pitchFamily="34" charset="-120"/>
               </a:rPr>
-              <a:t>کد واحدهایی که به این سرور وصل شده‌اند روی ردیف با برچسب نمایش داده می‌شود.</a:t>
+              <a:t>کد واحدهایی که به این سرور وصل شده‌اند روی ردیف با برچسب نمایش داده می‌شود.‏</a:t>
             </a:r>
             <a:endParaRPr lang="en-US" sz="1300" dirty="0"/>
           </a:p>
@@ -7232,7 +7232,7 @@
           <a:bodyPr wrap="square" lIns="0" tIns="0" rIns="0" bIns="0" rtlCol="0" anchor="ctr"/>
           <a:lstStyle/>
           <a:p>
-            <a:pPr algn="r" indent="0" marL="0">
+            <a:pPr rtl="1" algn="r" indent="0" marL="0">
               <a:buNone/>
             </a:pPr>
             <a:r>
@@ -7271,7 +7271,7 @@
           <a:bodyPr wrap="square" lIns="0" tIns="0" rIns="0" bIns="0" rtlCol="0" anchor="t"/>
           <a:lstStyle/>
           <a:p>
-            <a:pPr algn="r" indent="0" marL="0">
+            <a:pPr rtl="1" algn="r" indent="0" marL="0">
               <a:buNone/>
             </a:pPr>
             <a:r>
@@ -7283,7 +7283,7 @@
                 <a:ea typeface="Tahoma" pitchFamily="34" charset="-122"/>
                 <a:cs typeface="Tahoma" pitchFamily="34" charset="-120"/>
               </a:rPr>
-              <a:t>نقطه سبز یعنی سرور فعال و در دسترس است. بدون آن، ارتباط واحدها ممکن است قطع باشد.</a:t>
+              <a:t>نقطه سبز یعنی سرور فعال و در دسترس است.‏ بدون آن، ارتباط واحدها ممکن است قطع باشد.‏</a:t>
             </a:r>
             <a:endParaRPr lang="en-US" sz="1300" dirty="0"/>
           </a:p>
@@ -7357,7 +7357,7 @@
           <a:bodyPr wrap="square" lIns="0" tIns="0" rIns="0" bIns="0" rtlCol="0" anchor="ctr"/>
           <a:lstStyle/>
           <a:p>
-            <a:pPr algn="r" indent="0" marL="0">
+            <a:pPr rtl="1" algn="r" indent="0" marL="0">
               <a:buNone/>
             </a:pPr>
             <a:r>
@@ -7396,7 +7396,7 @@
           <a:bodyPr wrap="square" lIns="0" tIns="0" rIns="0" bIns="0" rtlCol="0" anchor="t"/>
           <a:lstStyle/>
           <a:p>
-            <a:pPr algn="r" indent="0" marL="0">
+            <a:pPr rtl="1" algn="r" indent="0" marL="0">
               <a:buNone/>
             </a:pPr>
             <a:r>
@@ -7408,7 +7408,7 @@
                 <a:ea typeface="Tahoma" pitchFamily="34" charset="-122"/>
                 <a:cs typeface="Tahoma" pitchFamily="34" charset="-120"/>
               </a:rPr>
-              <a:t>Place Holder برای واحدهایی است که هنوز سرور مشخصی ندارند؛ موقتی است تا سرور اصلی تعریف شود.</a:t>
+              <a:t>Place Holder برای واحدهایی است که هنوز سرور مشخصی ندارند؛ موقتی است تا سرور اصلی تعریف شود.‏</a:t>
             </a:r>
             <a:endParaRPr lang="en-US" sz="1300" dirty="0"/>
           </a:p>
@@ -8255,7 +8255,7 @@
           <a:bodyPr wrap="square" lIns="0" tIns="0" rIns="0" bIns="0" rtlCol="0" anchor="ctr"/>
           <a:lstStyle/>
           <a:p>
-            <a:pPr algn="r" indent="0" marL="0">
+            <a:pPr rtl="1" algn="r" indent="0" marL="0">
               <a:buNone/>
             </a:pPr>
             <a:r>
@@ -8294,7 +8294,7 @@
           <a:bodyPr wrap="square" lIns="0" tIns="0" rIns="0" bIns="0" rtlCol="0" anchor="t"/>
           <a:lstStyle/>
           <a:p>
-            <a:pPr algn="r" indent="0" marL="0">
+            <a:pPr rtl="1" algn="r" indent="0" marL="0">
               <a:buNone/>
             </a:pPr>
             <a:r>
@@ -8306,7 +8306,7 @@
                 <a:ea typeface="Tahoma" pitchFamily="34" charset="-122"/>
                 <a:cs typeface="Tahoma" pitchFamily="34" charset="-120"/>
               </a:rPr>
-              <a:t>حساب تازه بسازید و نام کاربری، مشخصات، تماس و نقش را برایش ثبت کنید.</a:t>
+              <a:t>حساب تازه بسازید و نام کاربری، مشخصات، تماس و نقش را برایش ثبت کنید.‏</a:t>
             </a:r>
             <a:endParaRPr lang="en-US" sz="1300" dirty="0"/>
           </a:p>
@@ -8380,7 +8380,7 @@
           <a:bodyPr wrap="square" lIns="0" tIns="0" rIns="0" bIns="0" rtlCol="0" anchor="ctr"/>
           <a:lstStyle/>
           <a:p>
-            <a:pPr algn="r" indent="0" marL="0">
+            <a:pPr rtl="1" algn="r" indent="0" marL="0">
               <a:buNone/>
             </a:pPr>
             <a:r>
@@ -8419,7 +8419,7 @@
           <a:bodyPr wrap="square" lIns="0" tIns="0" rIns="0" bIns="0" rtlCol="0" anchor="t"/>
           <a:lstStyle/>
           <a:p>
-            <a:pPr algn="r" indent="0" marL="0">
+            <a:pPr rtl="1" algn="r" indent="0" marL="0">
               <a:buNone/>
             </a:pPr>
             <a:r>
@@ -8431,7 +8431,7 @@
                 <a:ea typeface="Tahoma" pitchFamily="34" charset="-122"/>
                 <a:cs typeface="Tahoma" pitchFamily="34" charset="-120"/>
               </a:rPr>
-              <a:t>همان نامی است که کاربر هنگام ورود به سامانه وارد می‌کند.</a:t>
+              <a:t>همان نامی است که کاربر هنگام ورود به سامانه وارد می‌کند.‏</a:t>
             </a:r>
             <a:endParaRPr lang="en-US" sz="1300" dirty="0"/>
           </a:p>
@@ -8505,7 +8505,7 @@
           <a:bodyPr wrap="square" lIns="0" tIns="0" rIns="0" bIns="0" rtlCol="0" anchor="ctr"/>
           <a:lstStyle/>
           <a:p>
-            <a:pPr algn="r" indent="0" marL="0">
+            <a:pPr rtl="1" algn="r" indent="0" marL="0">
               <a:buNone/>
             </a:pPr>
             <a:r>
@@ -8544,7 +8544,7 @@
           <a:bodyPr wrap="square" lIns="0" tIns="0" rIns="0" bIns="0" rtlCol="0" anchor="t"/>
           <a:lstStyle/>
           <a:p>
-            <a:pPr algn="r" indent="0" marL="0">
+            <a:pPr rtl="1" algn="r" indent="0" marL="0">
               <a:buNone/>
             </a:pPr>
             <a:r>
@@ -8556,7 +8556,7 @@
                 <a:ea typeface="Tahoma" pitchFamily="34" charset="-122"/>
                 <a:cs typeface="Tahoma" pitchFamily="34" charset="-120"/>
               </a:rPr>
-              <a:t>مشخصات فردی ثبت‌شده برای شناسایی صاحب حساب در فهرست و پشتیبانی.</a:t>
+              <a:t>مشخصات فردی ثبت‌شده برای شناسایی صاحب حساب در فهرست و پشتیبانی.‏</a:t>
             </a:r>
             <a:endParaRPr lang="en-US" sz="1300" dirty="0"/>
           </a:p>
@@ -8630,7 +8630,7 @@
           <a:bodyPr wrap="square" lIns="0" tIns="0" rIns="0" bIns="0" rtlCol="0" anchor="ctr"/>
           <a:lstStyle/>
           <a:p>
-            <a:pPr algn="r" indent="0" marL="0">
+            <a:pPr rtl="1" algn="r" indent="0" marL="0">
               <a:buNone/>
             </a:pPr>
             <a:r>
@@ -8669,7 +8669,7 @@
           <a:bodyPr wrap="square" lIns="0" tIns="0" rIns="0" bIns="0" rtlCol="0" anchor="t"/>
           <a:lstStyle/>
           <a:p>
-            <a:pPr algn="r" indent="0" marL="0">
+            <a:pPr rtl="1" algn="r" indent="0" marL="0">
               <a:buNone/>
             </a:pPr>
             <a:r>
@@ -8681,7 +8681,7 @@
                 <a:ea typeface="Tahoma" pitchFamily="34" charset="-122"/>
                 <a:cs typeface="Tahoma" pitchFamily="34" charset="-120"/>
               </a:rPr>
-              <a:t>راه‌های تماس ثبت‌شده برای اطلاع‌رسانی یا بازیابی دسترسی.</a:t>
+              <a:t>راه‌های تماس ثبت‌شده برای اطلاع‌رسانی یا بازیابی دسترسی.‏</a:t>
             </a:r>
             <a:endParaRPr lang="en-US" sz="1300" dirty="0"/>
           </a:p>
@@ -8755,7 +8755,7 @@
           <a:bodyPr wrap="square" lIns="0" tIns="0" rIns="0" bIns="0" rtlCol="0" anchor="ctr"/>
           <a:lstStyle/>
           <a:p>
-            <a:pPr algn="r" indent="0" marL="0">
+            <a:pPr rtl="1" algn="r" indent="0" marL="0">
               <a:buNone/>
             </a:pPr>
             <a:r>
@@ -8794,7 +8794,7 @@
           <a:bodyPr wrap="square" lIns="0" tIns="0" rIns="0" bIns="0" rtlCol="0" anchor="t"/>
           <a:lstStyle/>
           <a:p>
-            <a:pPr algn="r" indent="0" marL="0">
+            <a:pPr rtl="1" algn="r" indent="0" marL="0">
               <a:buNone/>
             </a:pPr>
             <a:r>
@@ -8806,7 +8806,7 @@
                 <a:ea typeface="Tahoma" pitchFamily="34" charset="-122"/>
                 <a:cs typeface="Tahoma" pitchFamily="34" charset="-120"/>
               </a:rPr>
-              <a:t>زمان ساخته شدن حساب تا مشخص باشد از کی در سامانه فعال شده است.</a:t>
+              <a:t>زمان ساخته شدن حساب تا مشخص باشد از کی در سامانه فعال شده است.‏</a:t>
             </a:r>
             <a:endParaRPr lang="en-US" sz="1300" dirty="0"/>
           </a:p>
@@ -8880,7 +8880,7 @@
           <a:bodyPr wrap="square" lIns="0" tIns="0" rIns="0" bIns="0" rtlCol="0" anchor="ctr"/>
           <a:lstStyle/>
           <a:p>
-            <a:pPr algn="r" indent="0" marL="0">
+            <a:pPr rtl="1" algn="r" indent="0" marL="0">
               <a:buNone/>
             </a:pPr>
             <a:r>
@@ -8919,7 +8919,7 @@
           <a:bodyPr wrap="square" lIns="0" tIns="0" rIns="0" bIns="0" rtlCol="0" anchor="t"/>
           <a:lstStyle/>
           <a:p>
-            <a:pPr algn="r" indent="0" marL="0">
+            <a:pPr rtl="1" algn="r" indent="0" marL="0">
               <a:buNone/>
             </a:pPr>
             <a:r>
@@ -8931,7 +8931,7 @@
                 <a:ea typeface="Tahoma" pitchFamily="34" charset="-122"/>
                 <a:cs typeface="Tahoma" pitchFamily="34" charset="-120"/>
               </a:rPr>
-              <a:t>سطح دسترسی مثل Admin، Manager، Maintainer یا کاربر عادی را تعیین می‌کند.</a:t>
+              <a:t>سطح دسترسی مثل Admin، Manager، Maintainer یا کاربر عادی را تعیین می‌کند.‏</a:t>
             </a:r>
             <a:endParaRPr lang="en-US" sz="1300" dirty="0"/>
           </a:p>
@@ -9005,7 +9005,7 @@
           <a:bodyPr wrap="square" lIns="0" tIns="0" rIns="0" bIns="0" rtlCol="0" anchor="ctr"/>
           <a:lstStyle/>
           <a:p>
-            <a:pPr algn="r" indent="0" marL="0">
+            <a:pPr rtl="1" algn="r" indent="0" marL="0">
               <a:buNone/>
             </a:pPr>
             <a:r>
@@ -9044,7 +9044,7 @@
           <a:bodyPr wrap="square" lIns="0" tIns="0" rIns="0" bIns="0" rtlCol="0" anchor="t"/>
           <a:lstStyle/>
           <a:p>
-            <a:pPr algn="r" indent="0" marL="0">
+            <a:pPr rtl="1" algn="r" indent="0" marL="0">
               <a:buNone/>
             </a:pPr>
             <a:r>
@@ -9056,7 +9056,7 @@
                 <a:ea typeface="Tahoma" pitchFamily="34" charset="-122"/>
                 <a:cs typeface="Tahoma" pitchFamily="34" charset="-120"/>
               </a:rPr>
-              <a:t>اگر تعداد کاربران زیاد باشد، با صفحه‌بندی بین صفحات فهرست جابه‌جا شوید.</a:t>
+              <a:t>اگر تعداد کاربران زیاد باشد، با صفحه‌بندی بین صفحات فهرست جابه‌جا شوید.‏</a:t>
             </a:r>
             <a:endParaRPr lang="en-US" sz="1300" dirty="0"/>
           </a:p>
@@ -9130,7 +9130,7 @@
           <a:bodyPr wrap="square" lIns="0" tIns="0" rIns="0" bIns="0" rtlCol="0" anchor="ctr"/>
           <a:lstStyle/>
           <a:p>
-            <a:pPr algn="r" indent="0" marL="0">
+            <a:pPr rtl="1" algn="r" indent="0" marL="0">
               <a:buNone/>
             </a:pPr>
             <a:r>
@@ -9169,7 +9169,7 @@
           <a:bodyPr wrap="square" lIns="0" tIns="0" rIns="0" bIns="0" rtlCol="0" anchor="t"/>
           <a:lstStyle/>
           <a:p>
-            <a:pPr algn="r" indent="0" marL="0">
+            <a:pPr rtl="1" algn="r" indent="0" marL="0">
               <a:buNone/>
             </a:pPr>
             <a:r>
@@ -9181,7 +9181,7 @@
                 <a:ea typeface="Tahoma" pitchFamily="34" charset="-122"/>
                 <a:cs typeface="Tahoma" pitchFamily="34" charset="-120"/>
               </a:rPr>
-              <a:t>با کادر فیلتر می‌توانید سریع یک حساب را بین همه کاربران پیدا کنید.</a:t>
+              <a:t>با کادر فیلتر می‌توانید سریع یک حساب را بین همه کاربران پیدا کنید.‏</a:t>
             </a:r>
             <a:endParaRPr lang="en-US" sz="1300" dirty="0"/>
           </a:p>
@@ -13768,7 +13768,7 @@
           <a:bodyPr wrap="square" lIns="0" tIns="0" rIns="0" bIns="0" rtlCol="0" anchor="ctr"/>
           <a:lstStyle/>
           <a:p>
-            <a:pPr algn="r" indent="0" marL="0">
+            <a:pPr rtl="1" algn="r" indent="0" marL="0">
               <a:buNone/>
             </a:pPr>
             <a:r>
@@ -13807,7 +13807,7 @@
           <a:bodyPr wrap="square" lIns="0" tIns="0" rIns="0" bIns="0" rtlCol="0" anchor="t"/>
           <a:lstStyle/>
           <a:p>
-            <a:pPr algn="r" indent="0" marL="0">
+            <a:pPr rtl="1" algn="r" indent="0" marL="0">
               <a:buNone/>
             </a:pPr>
             <a:r>
@@ -13819,7 +13819,7 @@
                 <a:ea typeface="Tahoma" pitchFamily="34" charset="-122"/>
                 <a:cs typeface="Tahoma" pitchFamily="34" charset="-120"/>
               </a:rPr>
-              <a:t>واحد لبه تازه را از همین صفحه تعریف کنید تا در سامانه ثبت شود و بعداً در فهرست کامل هم دیده شود.</a:t>
+              <a:t>واحد لبه تازه را از همین صفحه تعریف کنید تا در سامانه ثبت شود و بعداً در فهرست کامل هم دیده شود.‏</a:t>
             </a:r>
             <a:endParaRPr lang="en-US" sz="1300" dirty="0"/>
           </a:p>
@@ -13893,7 +13893,7 @@
           <a:bodyPr wrap="square" lIns="0" tIns="0" rIns="0" bIns="0" rtlCol="0" anchor="ctr"/>
           <a:lstStyle/>
           <a:p>
-            <a:pPr algn="r" indent="0" marL="0">
+            <a:pPr rtl="1" algn="r" indent="0" marL="0">
               <a:buNone/>
             </a:pPr>
             <a:r>
@@ -13932,7 +13932,7 @@
           <a:bodyPr wrap="square" lIns="0" tIns="0" rIns="0" bIns="0" rtlCol="0" anchor="t"/>
           <a:lstStyle/>
           <a:p>
-            <a:pPr algn="r" indent="0" marL="0">
+            <a:pPr rtl="1" algn="r" indent="0" marL="0">
               <a:buNone/>
             </a:pPr>
             <a:r>
@@ -13944,7 +13944,7 @@
                 <a:ea typeface="Tahoma" pitchFamily="34" charset="-122"/>
                 <a:cs typeface="Tahoma" pitchFamily="34" charset="-120"/>
               </a:rPr>
-              <a:t>واحدها زیر نام ساختمان قرار می‌گیرند؛ مثلاً هدیش، مهرگان یا پالادیوم تا پیدا کردنشان ساده‌تر باشد.</a:t>
+              <a:t>واحدها زیر نام ساختمان قرار می‌گیرند؛ مثلاً هدیش، مهرگان یا پالادیوم تا پیدا کردنشان ساده‌تر باشد.‏</a:t>
             </a:r>
             <a:endParaRPr lang="en-US" sz="1300" dirty="0"/>
           </a:p>
@@ -14018,7 +14018,7 @@
           <a:bodyPr wrap="square" lIns="0" tIns="0" rIns="0" bIns="0" rtlCol="0" anchor="ctr"/>
           <a:lstStyle/>
           <a:p>
-            <a:pPr algn="r" indent="0" marL="0">
+            <a:pPr rtl="1" algn="r" indent="0" marL="0">
               <a:buNone/>
             </a:pPr>
             <a:r>
@@ -14057,7 +14057,7 @@
           <a:bodyPr wrap="square" lIns="0" tIns="0" rIns="0" bIns="0" rtlCol="0" anchor="t"/>
           <a:lstStyle/>
           <a:p>
-            <a:pPr algn="r" indent="0" marL="0">
+            <a:pPr rtl="1" algn="r" indent="0" marL="0">
               <a:buNone/>
             </a:pPr>
             <a:r>
@@ -14069,7 +14069,7 @@
                 <a:ea typeface="Tahoma" pitchFamily="34" charset="-122"/>
                 <a:cs typeface="Tahoma" pitchFamily="34" charset="-120"/>
               </a:rPr>
-              <a:t>روی کارت، کد واحد مثل E102، عنوان گروه، وضعیت آنلاین و تعداد آسانسور همان واحد دیده می‌شود.</a:t>
+              <a:t>روی کارت، کد واحد مثل E102، عنوان گروه، وضعیت آنلاین و تعداد آسانسور همان واحد دیده می‌شود.‏</a:t>
             </a:r>
             <a:endParaRPr lang="en-US" sz="1300" dirty="0"/>
           </a:p>
@@ -14143,7 +14143,7 @@
           <a:bodyPr wrap="square" lIns="0" tIns="0" rIns="0" bIns="0" rtlCol="0" anchor="ctr"/>
           <a:lstStyle/>
           <a:p>
-            <a:pPr algn="r" indent="0" marL="0">
+            <a:pPr rtl="1" algn="r" indent="0" marL="0">
               <a:buNone/>
             </a:pPr>
             <a:r>
@@ -14182,7 +14182,7 @@
           <a:bodyPr wrap="square" lIns="0" tIns="0" rIns="0" bIns="0" rtlCol="0" anchor="t"/>
           <a:lstStyle/>
           <a:p>
-            <a:pPr algn="r" indent="0" marL="0">
+            <a:pPr rtl="1" algn="r" indent="0" marL="0">
               <a:buNone/>
             </a:pPr>
             <a:r>
@@ -14194,7 +14194,7 @@
                 <a:ea typeface="Tahoma" pitchFamily="34" charset="-122"/>
                 <a:cs typeface="Tahoma" pitchFamily="34" charset="-120"/>
               </a:rPr>
-              <a:t>نقطه سبز کنار کد یعنی واحد الان متصل و در دسترس است. اگر سبز نباشد، واحد آفلاین است.</a:t>
+              <a:t>نقطه سبز کنار کد یعنی واحد الان متصل و در دسترس است.‏ اگر سبز نباشد، واحد آفلاین است.‏</a:t>
             </a:r>
             <a:endParaRPr lang="en-US" sz="1300" dirty="0"/>
           </a:p>
@@ -14268,7 +14268,7 @@
           <a:bodyPr wrap="square" lIns="0" tIns="0" rIns="0" bIns="0" rtlCol="0" anchor="ctr"/>
           <a:lstStyle/>
           <a:p>
-            <a:pPr algn="r" indent="0" marL="0">
+            <a:pPr rtl="1" algn="r" indent="0" marL="0">
               <a:buNone/>
             </a:pPr>
             <a:r>
@@ -14307,7 +14307,7 @@
           <a:bodyPr wrap="square" lIns="0" tIns="0" rIns="0" bIns="0" rtlCol="0" anchor="t"/>
           <a:lstStyle/>
           <a:p>
-            <a:pPr algn="r" indent="0" marL="0">
+            <a:pPr rtl="1" algn="r" indent="0" marL="0">
               <a:buNone/>
             </a:pPr>
             <a:r>
@@ -14319,7 +14319,7 @@
                 <a:ea typeface="Tahoma" pitchFamily="34" charset="-122"/>
                 <a:cs typeface="Tahoma" pitchFamily="34" charset="-120"/>
               </a:rPr>
-              <a:t>عدد پایین کارت نشان می‌دهد چند آسانسور به آن واحد وصل شده‌اند.</a:t>
+              <a:t>عدد پایین کارت نشان می‌دهد چند آسانسور به آن واحد وصل شده‌اند.‏</a:t>
             </a:r>
             <a:endParaRPr lang="en-US" sz="1300" dirty="0"/>
           </a:p>
@@ -14328,131 +14328,6 @@
       <p:sp>
         <p:nvSpPr>
           <p:cNvPr id="25" name="Shape 23"/>
-          <p:cNvSpPr/>
-          <p:nvPr/>
-        </p:nvSpPr>
-        <p:spPr>
-          <a:xfrm>
-            <a:off x="411480" y="4700016"/>
-            <a:ext cx="5568696" cy="1700784"/>
-          </a:xfrm>
-          <a:prstGeom prst="roundRect">
-            <a:avLst>
-              <a:gd name="adj" fmla="val 5376"/>
-            </a:avLst>
-          </a:prstGeom>
-          <a:solidFill>
-            <a:srgbClr val="FFFFFF"/>
-          </a:solidFill>
-          <a:ln w="12700">
-            <a:solidFill>
-              <a:srgbClr val="E3E0D9"/>
-            </a:solidFill>
-            <a:prstDash val="solid"/>
-          </a:ln>
-        </p:spPr>
-      </p:sp>
-      <p:sp>
-        <p:nvSpPr>
-          <p:cNvPr id="26" name="Shape 24"/>
-          <p:cNvSpPr/>
-          <p:nvPr/>
-        </p:nvSpPr>
-        <p:spPr>
-          <a:xfrm>
-            <a:off x="5907024" y="4864608"/>
-            <a:ext cx="64008" cy="384048"/>
-          </a:xfrm>
-          <a:prstGeom prst="rect">
-            <a:avLst/>
-          </a:prstGeom>
-          <a:solidFill>
-            <a:srgbClr val="9C8774"/>
-          </a:solidFill>
-          <a:ln/>
-        </p:spPr>
-      </p:sp>
-      <p:sp>
-        <p:nvSpPr>
-          <p:cNvPr id="27" name="Text 25"/>
-          <p:cNvSpPr/>
-          <p:nvPr/>
-        </p:nvSpPr>
-        <p:spPr>
-          <a:xfrm>
-            <a:off x="612648" y="4828032"/>
-            <a:ext cx="5148072" cy="310896"/>
-          </a:xfrm>
-          <a:prstGeom prst="rect">
-            <a:avLst/>
-          </a:prstGeom>
-          <a:noFill/>
-          <a:ln/>
-        </p:spPr>
-        <p:txBody>
-          <a:bodyPr wrap="square" lIns="0" tIns="0" rIns="0" bIns="0" rtlCol="0" anchor="ctr"/>
-          <a:lstStyle/>
-          <a:p>
-            <a:pPr algn="r" indent="0" marL="0">
-              <a:buNone/>
-            </a:pPr>
-            <a:r>
-              <a:rPr lang="en-US" sz="1500" b="1" dirty="0">
-                <a:solidFill>
-                  <a:srgbClr val="2B2B29"/>
-                </a:solidFill>
-                <a:latin typeface="Tahoma" pitchFamily="34" charset="0"/>
-                <a:ea typeface="Tahoma" pitchFamily="34" charset="-122"/>
-                <a:cs typeface="Tahoma" pitchFamily="34" charset="-120"/>
-              </a:rPr>
-              <a:t>پین دسترسی سریع</a:t>
-            </a:r>
-            <a:endParaRPr lang="en-US" sz="1500" dirty="0"/>
-          </a:p>
-        </p:txBody>
-      </p:sp>
-      <p:sp>
-        <p:nvSpPr>
-          <p:cNvPr id="28" name="Text 26"/>
-          <p:cNvSpPr/>
-          <p:nvPr/>
-        </p:nvSpPr>
-        <p:spPr>
-          <a:xfrm>
-            <a:off x="612648" y="5138928"/>
-            <a:ext cx="5148072" cy="1115568"/>
-          </a:xfrm>
-          <a:prstGeom prst="rect">
-            <a:avLst/>
-          </a:prstGeom>
-          <a:noFill/>
-          <a:ln/>
-        </p:spPr>
-        <p:txBody>
-          <a:bodyPr wrap="square" lIns="0" tIns="0" rIns="0" bIns="0" rtlCol="0" anchor="t"/>
-          <a:lstStyle/>
-          <a:p>
-            <a:pPr algn="r" indent="0" marL="0">
-              <a:buNone/>
-            </a:pPr>
-            <a:r>
-              <a:rPr lang="en-US" sz="1300" dirty="0">
-                <a:solidFill>
-                  <a:srgbClr val="6F6F69"/>
-                </a:solidFill>
-                <a:latin typeface="Tahoma" pitchFamily="34" charset="0"/>
-                <a:ea typeface="Tahoma" pitchFamily="34" charset="-122"/>
-                <a:cs typeface="Tahoma" pitchFamily="34" charset="-120"/>
-              </a:rPr>
-              <a:t>واحدهای پرکاربرد را پین کنید تا همیشه در این صفحه باشند و لازم نباشد هر بار در فهرست بگردید.</a:t>
-            </a:r>
-            <a:endParaRPr lang="en-US" sz="1300" dirty="0"/>
-          </a:p>
-        </p:txBody>
-      </p:sp>
-      <p:sp>
-        <p:nvSpPr>
-          <p:cNvPr id="29" name="Shape 27"/>
           <p:cNvSpPr/>
           <p:nvPr/>
         </p:nvSpPr>
@@ -14472,7 +14347,7 @@
       </p:sp>
       <p:sp>
         <p:nvSpPr>
-          <p:cNvPr id="30" name="Text 28"/>
+          <p:cNvPr id="26" name="Text 24"/>
           <p:cNvSpPr/>
           <p:nvPr/>
         </p:nvSpPr>
@@ -14511,7 +14386,7 @@
       </p:sp>
       <p:sp>
         <p:nvSpPr>
-          <p:cNvPr id="31" name="Text 29"/>
+          <p:cNvPr id="27" name="Text 25"/>
           <p:cNvSpPr/>
           <p:nvPr/>
         </p:nvSpPr>

</xml_diff>